<commit_message>
Deck 5 (Treinamento + Portal) com a foto real do ABBA Portal
- Print real do painel do portal (trilhas, progresso, coach de IA) embutido
  no slide 'O quê', recortado sem a moldura do navegador
- Fecha a pendência do V3r; resta o card da Bússola em pt-BR
- Revisor: PASS

Co-Authored-By: Claude Fable 5 <noreply@anthropic.com>
Claude-Session: https://claude.ai/code/session_016RZJT8nVEB7u33HvjY5KvZ
</commit_message>
<xml_diff>
--- a/08-materiais/modelos/servico-5-treinamento-portal-deck.pptx
+++ b/08-materiais/modelos/servico-5-treinamento-portal-deck.pptx
@@ -1713,16 +1713,101 @@
           </a:p>
         </p:txBody>
       </p:sp>
-      <p:sp>
-        <p:nvSpPr>
-          <p:cNvPr id="4" name="Text 2"/>
+      <p:pic>
+        <p:nvPicPr>
+          <p:cNvPr id="4" name="Image 0" descr="/tmp/claude-0/-home-user/3b340934-06d1-5f26-b467-4c811e620256/scratchpad/fotos/portal-dashboard.jpg">    </p:cNvPr>
+          <p:cNvPicPr>
+            <a:picLocks noChangeAspect="1"/>
+          </p:cNvPicPr>
+          <p:nvPr/>
+        </p:nvPicPr>
+        <p:blipFill>
+          <a:blip r:embed="rId1"/>
+          <a:stretch>
+            <a:fillRect/>
+          </a:stretch>
+        </p:blipFill>
+        <p:spPr>
+          <a:xfrm>
+            <a:off x="7159752" y="2057400"/>
+            <a:ext cx="4206240" cy="2377440"/>
+          </a:xfrm>
+          <a:prstGeom prst="rect">
+            <a:avLst/>
+          </a:prstGeom>
+        </p:spPr>
+      </p:pic>
+      <p:sp>
+        <p:nvSpPr>
+          <p:cNvPr id="5" name="Shape 2"/>
+          <p:cNvSpPr/>
+          <p:nvPr/>
+        </p:nvSpPr>
+        <p:spPr>
+          <a:xfrm>
+            <a:off x="7159752" y="2057400"/>
+            <a:ext cx="4206240" cy="2377440"/>
+          </a:xfrm>
+          <a:prstGeom prst="rect">
+            <a:avLst/>
+          </a:prstGeom>
+          <a:ln w="12700">
+            <a:solidFill>
+              <a:srgbClr val="D9D2C4"/>
+            </a:solidFill>
+            <a:prstDash val="solid"/>
+          </a:ln>
+        </p:spPr>
+      </p:sp>
+      <p:sp>
+        <p:nvSpPr>
+          <p:cNvPr id="6" name="Text 3"/>
+          <p:cNvSpPr/>
+          <p:nvPr/>
+        </p:nvSpPr>
+        <p:spPr>
+          <a:xfrm>
+            <a:off x="6702552" y="4507992"/>
+            <a:ext cx="5120640" cy="274320"/>
+          </a:xfrm>
+          <a:prstGeom prst="rect">
+            <a:avLst/>
+          </a:prstGeom>
+          <a:noFill/>
+          <a:ln/>
+        </p:spPr>
+        <p:txBody>
+          <a:bodyPr wrap="square" lIns="0" tIns="0" rIns="0" bIns="0" rtlCol="0" anchor="ctr"/>
+          <a:lstStyle/>
+          <a:p>
+            <a:pPr algn="ctr" indent="0" marL="0">
+              <a:buNone/>
+            </a:pPr>
+            <a:r>
+              <a:rPr lang="en-US" sz="850" i="1" dirty="0">
+                <a:solidFill>
+                  <a:srgbClr val="5A6472"/>
+                </a:solidFill>
+                <a:latin typeface="Calibri" pitchFamily="34" charset="0"/>
+                <a:ea typeface="Calibri" pitchFamily="34" charset="-122"/>
+                <a:cs typeface="Calibri" pitchFamily="34" charset="-120"/>
+              </a:rPr>
+              <a:t>O ABBA Portal real — trilhas por nível, progresso e o coach de IA sempre presente.</a:t>
+            </a:r>
+            <a:endParaRPr lang="en-US" sz="850" dirty="0"/>
+          </a:p>
+        </p:txBody>
+      </p:sp>
+      <p:sp>
+        <p:nvSpPr>
+          <p:cNvPr id="7" name="Text 4"/>
           <p:cNvSpPr/>
           <p:nvPr/>
         </p:nvSpPr>
         <p:spPr>
           <a:xfrm>
             <a:off x="822960" y="2103120"/>
-            <a:ext cx="9875520" cy="1143000"/>
+            <a:ext cx="5925312" cy="1371600"/>
           </a:xfrm>
           <a:prstGeom prst="rect">
             <a:avLst/>
@@ -1757,14 +1842,14 @@
       </p:sp>
       <p:sp>
         <p:nvSpPr>
-          <p:cNvPr id="5" name="Text 3"/>
-          <p:cNvSpPr/>
-          <p:nvPr/>
-        </p:nvSpPr>
-        <p:spPr>
-          <a:xfrm>
-            <a:off x="822960" y="3337560"/>
-            <a:ext cx="9875520" cy="1143000"/>
+          <p:cNvPr id="8" name="Text 5"/>
+          <p:cNvSpPr/>
+          <p:nvPr/>
+        </p:nvSpPr>
+        <p:spPr>
+          <a:xfrm>
+            <a:off x="822960" y="3566160"/>
+            <a:ext cx="5925312" cy="1371600"/>
           </a:xfrm>
           <a:prstGeom prst="rect">
             <a:avLst/>
@@ -1799,7 +1884,7 @@
       </p:sp>
       <p:sp>
         <p:nvSpPr>
-          <p:cNvPr id="6" name="Shape 4"/>
+          <p:cNvPr id="9" name="Shape 6"/>
           <p:cNvSpPr/>
           <p:nvPr/>
         </p:nvSpPr>
@@ -1822,7 +1907,7 @@
       </p:sp>
       <p:sp>
         <p:nvSpPr>
-          <p:cNvPr id="7" name="Text 5"/>
+          <p:cNvPr id="10" name="Text 7"/>
           <p:cNvSpPr/>
           <p:nvPr/>
         </p:nvSpPr>
@@ -1861,7 +1946,7 @@
       </p:sp>
       <p:sp>
         <p:nvSpPr>
-          <p:cNvPr id="8" name="Text 6"/>
+          <p:cNvPr id="11" name="Text 8"/>
           <p:cNvSpPr/>
           <p:nvPr/>
         </p:nvSpPr>

</xml_diff>